<commit_message>
Deixa claro que toda decisao precisa ser enviada (interno ou cliente), sem excecao - app, manual, PDF e PPTX
</commit_message>
<xml_diff>
--- a/manual.pptx
+++ b/manual.pptx
@@ -6517,8 +6517,8 @@
         </p:nvSpPr>
         <p:spPr>
           <a:xfrm>
-            <a:off x="685800" y="3611880"/>
-            <a:ext cx="10835640" cy="1417320"/>
+            <a:off x="685800" y="3566160"/>
+            <a:ext cx="10835640" cy="1691640"/>
           </a:xfrm>
           <a:prstGeom prst="roundRect">
             <a:avLst>
@@ -6572,8 +6572,8 @@
         </p:nvSpPr>
         <p:spPr>
           <a:xfrm>
-            <a:off x="896112" y="3749039"/>
-            <a:ext cx="10424160" cy="1188720"/>
+            <a:off x="896112" y="3675887"/>
+            <a:ext cx="10424160" cy="1508760"/>
           </a:xfrm>
           <a:prstGeom prst="rect">
             <a:avLst/>
@@ -6598,7 +6598,7 @@
                 </a:solidFill>
                 <a:latin typeface="Calibri"/>
               </a:rPr>
-              <a:t>✉️  Regra de envio</a:t>
+              <a:t>✉️  Regra de envio — toda decisão é enviada, sempre</a:t>
             </a:r>
           </a:p>
           <a:p>
@@ -6607,25 +6607,44 @@
                 <a:spcPct val="115000"/>
               </a:lnSpc>
               <a:spcAft>
-                <a:spcPts val="400"/>
+                <a:spcPts val="600"/>
+              </a:spcAft>
+            </a:pPr>
+            <a:r>
+              <a:rPr sz="1150" b="1" i="0">
+                <a:solidFill>
+                  <a:srgbClr val="C0392B"/>
+                </a:solidFill>
+                <a:latin typeface="Calibri"/>
+              </a:rPr>
+              <a:t>"Envio para o Cliente" decide só PRA QUEM vai — nunca SE vai. Não existe reporte sem envio.</a:t>
+            </a:r>
+          </a:p>
+          <a:p>
+            <a:pPr algn="l">
+              <a:lnSpc>
+                <a:spcPct val="110000"/>
+              </a:lnSpc>
+              <a:spcAft>
+                <a:spcPts val="300"/>
               </a:spcAft>
               <a:buFont typeface="Calibri"/>
               <a:buChar char="—"/>
             </a:pPr>
             <a:r>
-              <a:rPr sz="1150" b="0" i="0">
+              <a:rPr sz="1100" b="0" i="0">
                 <a:solidFill>
                   <a:srgbClr val="2D2926"/>
                 </a:solidFill>
                 <a:latin typeface="Calibri"/>
               </a:rPr>
-              <a:t>  Envio para o Cliente = Sim  →  Higor Viali + Maria Muller (+ Shana, se "Inserir Gerência" = Sim) — cc Grupo Bridgestone</a:t>
+              <a:t>  Sim  →  Higor Viali + Maria Muller (+ Shana, se "Inserir Gerência" = Sim) — cc Grupo Bridgestone</a:t>
             </a:r>
           </a:p>
           <a:p>
             <a:pPr algn="l">
               <a:lnSpc>
-                <a:spcPct val="115000"/>
+                <a:spcPct val="110000"/>
               </a:lnSpc>
               <a:spcAft>
                 <a:spcPts val="0"/>
@@ -6634,13 +6653,13 @@
               <a:buChar char="—"/>
             </a:pPr>
             <a:r>
-              <a:rPr sz="1150" b="0" i="0">
+              <a:rPr sz="1100" b="0" i="0">
                 <a:solidFill>
                   <a:srgbClr val="2D2926"/>
                 </a:solidFill>
                 <a:latin typeface="Calibri"/>
               </a:rPr>
-              <a:t>  Envio para o Cliente = Não  →  fica só interno, vai só pro Grupo Bridgestone</a:t>
+              <a:t>  Não  →  fica só interno, vai só pro Grupo Bridgestone (mas ainda é enviado)</a:t>
             </a:r>
           </a:p>
         </p:txBody>
@@ -6653,8 +6672,8 @@
         </p:nvSpPr>
         <p:spPr>
           <a:xfrm>
-            <a:off x="685800" y="5212080"/>
-            <a:ext cx="10835640" cy="868680"/>
+            <a:off x="685800" y="5440680"/>
+            <a:ext cx="10835640" cy="777240"/>
           </a:xfrm>
           <a:prstGeom prst="roundRect">
             <a:avLst>
@@ -6699,8 +6718,8 @@
         </p:nvSpPr>
         <p:spPr>
           <a:xfrm>
-            <a:off x="886968" y="5303520"/>
-            <a:ext cx="10433304" cy="685800"/>
+            <a:off x="886968" y="5532120"/>
+            <a:ext cx="10433304" cy="594359"/>
           </a:xfrm>
           <a:prstGeom prst="rect">
             <a:avLst/>
@@ -6719,7 +6738,7 @@
               </a:lnSpc>
             </a:pPr>
             <a:r>
-              <a:rPr sz="1150">
+              <a:rPr sz="1100">
                 <a:solidFill>
                   <a:srgbClr val="C0392B"/>
                 </a:solidFill>

</xml_diff>